<commit_message>
final touch for lesson 1
</commit_message>
<xml_diff>
--- a/ppt/Introduction.pptx
+++ b/ppt/Introduction.pptx
@@ -5,13 +5,14 @@
     <p:sldMasterId id="2147483648" r:id="rId1"/>
   </p:sldMasterIdLst>
   <p:notesMasterIdLst>
-    <p:notesMasterId r:id="rId6"/>
+    <p:notesMasterId r:id="rId7"/>
   </p:notesMasterIdLst>
   <p:sldIdLst>
     <p:sldId id="256" r:id="rId2"/>
     <p:sldId id="257" r:id="rId3"/>
     <p:sldId id="259" r:id="rId4"/>
     <p:sldId id="258" r:id="rId5"/>
+    <p:sldId id="260" r:id="rId6"/>
   </p:sldIdLst>
   <p:sldSz cx="12192000" cy="6858000"/>
   <p:notesSz cx="6858000" cy="9144000"/>
@@ -200,7 +201,7 @@
           <a:p>
             <a:fld id="{EC8BB85A-32EA-4945-B5D2-D1163F5D41BD}" type="datetimeFigureOut">
               <a:rPr lang="en-US" smtClean="0"/>
-              <a:t>4/19/26</a:t>
+              <a:t>4/20/26</a:t>
             </a:fld>
             <a:endParaRPr lang="en-US"/>
           </a:p>
@@ -617,7 +618,7 @@
           <a:p>
             <a:fld id="{DF10EF62-F446-6F43-BED0-ACB95000D398}" type="datetime1">
               <a:rPr lang="it-IT" smtClean="0"/>
-              <a:t>19/04/26</a:t>
+              <a:t>20/04/26</a:t>
             </a:fld>
             <a:endParaRPr lang="en-US"/>
           </a:p>
@@ -820,7 +821,7 @@
           <a:p>
             <a:fld id="{D92442F8-9FB9-B44C-97C5-B31BABE739D1}" type="datetime1">
               <a:rPr lang="it-IT" smtClean="0"/>
-              <a:t>19/04/26</a:t>
+              <a:t>20/04/26</a:t>
             </a:fld>
             <a:endParaRPr lang="en-US"/>
           </a:p>
@@ -1033,7 +1034,7 @@
           <a:p>
             <a:fld id="{306CF0C3-9551-904E-8E6F-6CC89B571946}" type="datetime1">
               <a:rPr lang="it-IT" smtClean="0"/>
-              <a:t>19/04/26</a:t>
+              <a:t>20/04/26</a:t>
             </a:fld>
             <a:endParaRPr lang="en-US"/>
           </a:p>
@@ -1285,7 +1286,7 @@
           <a:p>
             <a:fld id="{67E5F536-1DD7-6846-B8D2-5D585A7FBD09}" type="datetime1">
               <a:rPr lang="it-IT" smtClean="0"/>
-              <a:t>19/04/26</a:t>
+              <a:t>20/04/26</a:t>
             </a:fld>
             <a:endParaRPr lang="en-US"/>
           </a:p>
@@ -1601,7 +1602,7 @@
           <a:p>
             <a:fld id="{6490FA0E-D734-9740-8C0B-B6D38CF56729}" type="datetime1">
               <a:rPr lang="it-IT" smtClean="0"/>
-              <a:t>19/04/26</a:t>
+              <a:t>20/04/26</a:t>
             </a:fld>
             <a:endParaRPr lang="en-US"/>
           </a:p>
@@ -1872,7 +1873,7 @@
           <a:p>
             <a:fld id="{BFEF1D20-E45E-044E-8D11-494FE8F16ED9}" type="datetime1">
               <a:rPr lang="it-IT" smtClean="0"/>
-              <a:t>19/04/26</a:t>
+              <a:t>20/04/26</a:t>
             </a:fld>
             <a:endParaRPr lang="en-US"/>
           </a:p>
@@ -2290,7 +2291,7 @@
           <a:p>
             <a:fld id="{6C304DDC-56C7-4E4D-ADD2-CE078BCEBE1E}" type="datetime1">
               <a:rPr lang="it-IT" smtClean="0"/>
-              <a:t>19/04/26</a:t>
+              <a:t>20/04/26</a:t>
             </a:fld>
             <a:endParaRPr lang="en-US"/>
           </a:p>
@@ -2435,7 +2436,7 @@
           <a:p>
             <a:fld id="{32B2DA38-97DF-1A4A-BFFB-52C4161D8E3F}" type="datetime1">
               <a:rPr lang="it-IT" smtClean="0"/>
-              <a:t>19/04/26</a:t>
+              <a:t>20/04/26</a:t>
             </a:fld>
             <a:endParaRPr lang="en-US"/>
           </a:p>
@@ -2551,7 +2552,7 @@
           <a:p>
             <a:fld id="{7B5363E4-E357-964A-974B-D9BDA62924A0}" type="datetime1">
               <a:rPr lang="it-IT" smtClean="0"/>
-              <a:t>19/04/26</a:t>
+              <a:t>20/04/26</a:t>
             </a:fld>
             <a:endParaRPr lang="en-US"/>
           </a:p>
@@ -2867,7 +2868,7 @@
           <a:p>
             <a:fld id="{C09B094F-670D-A24C-943C-6AA010140A30}" type="datetime1">
               <a:rPr lang="it-IT" smtClean="0"/>
-              <a:t>19/04/26</a:t>
+              <a:t>20/04/26</a:t>
             </a:fld>
             <a:endParaRPr lang="en-US"/>
           </a:p>
@@ -3159,7 +3160,7 @@
           <a:p>
             <a:fld id="{35D95DD3-6CA2-994B-8156-21BFEA43D3FF}" type="datetime1">
               <a:rPr lang="it-IT" smtClean="0"/>
-              <a:t>19/04/26</a:t>
+              <a:t>20/04/26</a:t>
             </a:fld>
             <a:endParaRPr lang="en-US"/>
           </a:p>
@@ -3405,7 +3406,7 @@
           <a:p>
             <a:fld id="{EB063BD9-9DD8-FC46-8D76-8F3407787958}" type="datetime1">
               <a:rPr lang="it-IT" smtClean="0"/>
-              <a:t>19/04/26</a:t>
+              <a:t>20/04/26</a:t>
             </a:fld>
             <a:endParaRPr lang="en-US"/>
           </a:p>
@@ -4781,6 +4782,182 @@
     <p:extLst>
       <p:ext uri="{BB962C8B-B14F-4D97-AF65-F5344CB8AC3E}">
         <p14:creationId xmlns:p14="http://schemas.microsoft.com/office/powerpoint/2010/main" val="457538140"/>
+      </p:ext>
+    </p:extLst>
+  </p:cSld>
+  <p:clrMapOvr>
+    <a:masterClrMapping/>
+  </p:clrMapOvr>
+</p:sld>
+</file>
+
+<file path=ppt/slides/slide5.xml><?xml version="1.0" encoding="utf-8"?>
+<p:sld xmlns:a="http://schemas.openxmlformats.org/drawingml/2006/main" xmlns:r="http://schemas.openxmlformats.org/officeDocument/2006/relationships" xmlns:p="http://schemas.openxmlformats.org/presentationml/2006/main">
+  <p:cSld>
+    <p:spTree>
+      <p:nvGrpSpPr>
+        <p:cNvPr id="1" name=""/>
+        <p:cNvGrpSpPr/>
+        <p:nvPr/>
+      </p:nvGrpSpPr>
+      <p:grpSpPr>
+        <a:xfrm>
+          <a:off x="0" y="0"/>
+          <a:ext cx="0" cy="0"/>
+          <a:chOff x="0" y="0"/>
+          <a:chExt cx="0" cy="0"/>
+        </a:xfrm>
+      </p:grpSpPr>
+      <p:sp>
+        <p:nvSpPr>
+          <p:cNvPr id="2" name="Title 1">
+            <a:extLst>
+              <a:ext uri="{FF2B5EF4-FFF2-40B4-BE49-F238E27FC236}">
+                <a16:creationId xmlns:a16="http://schemas.microsoft.com/office/drawing/2014/main" id="{38A01E54-2158-B5E4-D7A9-7DA402086488}"/>
+              </a:ext>
+            </a:extLst>
+          </p:cNvPr>
+          <p:cNvSpPr>
+            <a:spLocks noGrp="1"/>
+          </p:cNvSpPr>
+          <p:nvPr>
+            <p:ph type="title"/>
+          </p:nvPr>
+        </p:nvSpPr>
+        <p:spPr/>
+        <p:txBody>
+          <a:bodyPr/>
+          <a:lstStyle/>
+          <a:p>
+            <a:r>
+              <a:rPr lang="en-US" dirty="0"/>
+              <a:t>Course material</a:t>
+            </a:r>
+          </a:p>
+        </p:txBody>
+      </p:sp>
+      <p:sp>
+        <p:nvSpPr>
+          <p:cNvPr id="3" name="Content Placeholder 2">
+            <a:extLst>
+              <a:ext uri="{FF2B5EF4-FFF2-40B4-BE49-F238E27FC236}">
+                <a16:creationId xmlns:a16="http://schemas.microsoft.com/office/drawing/2014/main" id="{F4CB1BAD-553E-265E-1E0A-536BDB9EA30C}"/>
+              </a:ext>
+            </a:extLst>
+          </p:cNvPr>
+          <p:cNvSpPr>
+            <a:spLocks noGrp="1"/>
+          </p:cNvSpPr>
+          <p:nvPr>
+            <p:ph idx="1"/>
+          </p:nvPr>
+        </p:nvSpPr>
+        <p:spPr/>
+        <p:txBody>
+          <a:bodyPr/>
+          <a:lstStyle/>
+          <a:p>
+            <a:r>
+              <a:rPr lang="en-US" dirty="0">
+                <a:hlinkClick r:id="rId2"/>
+              </a:rPr>
+              <a:t>https://miotsdata.github.io/R-course_2026/</a:t>
+            </a:r>
+            <a:endParaRPr lang="en-US" dirty="0"/>
+          </a:p>
+          <a:p>
+            <a:r>
+              <a:rPr lang="en-US" dirty="0">
+                <a:hlinkClick r:id="rId3"/>
+              </a:rPr>
+              <a:t>https://miotsdata.github.io/R-for-biologist/</a:t>
+            </a:r>
+            <a:endParaRPr lang="en-US" dirty="0"/>
+          </a:p>
+          <a:p>
+            <a:r>
+              <a:rPr lang="en-US" dirty="0">
+                <a:hlinkClick r:id="rId4"/>
+              </a:rPr>
+              <a:t>https://drive.google.com</a:t>
+            </a:r>
+            <a:r>
+              <a:rPr lang="en-US">
+                <a:hlinkClick r:id="rId4"/>
+              </a:rPr>
+              <a:t>/drive/folders/1jYSTKgpSu3FS5S-F_hgZRtuuZ6RAGeLX?usp=sharing</a:t>
+            </a:r>
+            <a:endParaRPr lang="en-US"/>
+          </a:p>
+          <a:p>
+            <a:endParaRPr lang="en-US" dirty="0"/>
+          </a:p>
+          <a:p>
+            <a:endParaRPr lang="en-US" dirty="0"/>
+          </a:p>
+        </p:txBody>
+      </p:sp>
+      <p:sp>
+        <p:nvSpPr>
+          <p:cNvPr id="4" name="Footer Placeholder 3">
+            <a:extLst>
+              <a:ext uri="{FF2B5EF4-FFF2-40B4-BE49-F238E27FC236}">
+                <a16:creationId xmlns:a16="http://schemas.microsoft.com/office/drawing/2014/main" id="{23105CCA-99FE-2A30-2D03-3C2A90385C7E}"/>
+              </a:ext>
+            </a:extLst>
+          </p:cNvPr>
+          <p:cNvSpPr>
+            <a:spLocks noGrp="1"/>
+          </p:cNvSpPr>
+          <p:nvPr>
+            <p:ph type="ftr" sz="quarter" idx="11"/>
+          </p:nvPr>
+        </p:nvSpPr>
+        <p:spPr/>
+        <p:txBody>
+          <a:bodyPr/>
+          <a:lstStyle/>
+          <a:p>
+            <a:r>
+              <a:rPr lang="en-US"/>
+              <a:t>Biostatistics - Use of R</a:t>
+            </a:r>
+          </a:p>
+        </p:txBody>
+      </p:sp>
+      <p:sp>
+        <p:nvSpPr>
+          <p:cNvPr id="5" name="Slide Number Placeholder 4">
+            <a:extLst>
+              <a:ext uri="{FF2B5EF4-FFF2-40B4-BE49-F238E27FC236}">
+                <a16:creationId xmlns:a16="http://schemas.microsoft.com/office/drawing/2014/main" id="{532AB1EB-541D-1FCD-7681-DB1E82C86B17}"/>
+              </a:ext>
+            </a:extLst>
+          </p:cNvPr>
+          <p:cNvSpPr>
+            <a:spLocks noGrp="1"/>
+          </p:cNvSpPr>
+          <p:nvPr>
+            <p:ph type="sldNum" sz="quarter" idx="12"/>
+          </p:nvPr>
+        </p:nvSpPr>
+        <p:spPr/>
+        <p:txBody>
+          <a:bodyPr/>
+          <a:lstStyle/>
+          <a:p>
+            <a:fld id="{38FD82B0-4230-0B4B-A50C-5E8EAAFF05B6}" type="slidenum">
+              <a:rPr lang="en-US" smtClean="0"/>
+              <a:t>5</a:t>
+            </a:fld>
+            <a:endParaRPr lang="en-US"/>
+          </a:p>
+        </p:txBody>
+      </p:sp>
+    </p:spTree>
+    <p:extLst>
+      <p:ext uri="{BB962C8B-B14F-4D97-AF65-F5344CB8AC3E}">
+        <p14:creationId xmlns:p14="http://schemas.microsoft.com/office/powerpoint/2010/main" val="1017297677"/>
       </p:ext>
     </p:extLst>
   </p:cSld>

</xml_diff>